<commit_message>
Use Luna for OpenAI development
</commit_message>
<xml_diff>
--- a/docs/lessons/assets/cah-023-openai-responses-adapter.pptx
+++ b/docs/lessons/assets/cah-023-openai-responses-adapter.pptx
@@ -2,18 +2,18 @@
 <file path=ppt/presentation.xml><?xml version="1.0" encoding="utf-8"?>
 <p:presentation xmlns:p="http://schemas.openxmlformats.org/presentationml/2006/main">
   <p:sldMasterIdLst>
-    <p:sldMasterId xmlns:r="http://schemas.openxmlformats.org/officeDocument/2006/relationships" id="2147483648" r:id="Rdce37dbd7e644a58"/>
+    <p:sldMasterId xmlns:r="http://schemas.openxmlformats.org/officeDocument/2006/relationships" id="2147483648" r:id="R58d24fbd8b614c88"/>
   </p:sldMasterIdLst>
   <p:notesMasterIdLst>
-    <p:notesMasterId xmlns:r="http://schemas.openxmlformats.org/officeDocument/2006/relationships" r:id="R0fa82bc7918b4d86"/>
+    <p:notesMasterId xmlns:r="http://schemas.openxmlformats.org/officeDocument/2006/relationships" r:id="R61e66b5ca0c243aa"/>
   </p:notesMasterIdLst>
   <p:sldIdLst>
-    <p:sldId xmlns:r="http://schemas.openxmlformats.org/officeDocument/2006/relationships" id="256" r:id="Raaf72977b5db48c1"/>
-    <p:sldId xmlns:r="http://schemas.openxmlformats.org/officeDocument/2006/relationships" id="257" r:id="R43132f535512466a"/>
-    <p:sldId xmlns:r="http://schemas.openxmlformats.org/officeDocument/2006/relationships" id="258" r:id="R2146f87d317249c3"/>
-    <p:sldId xmlns:r="http://schemas.openxmlformats.org/officeDocument/2006/relationships" id="259" r:id="R4feb6e388c224300"/>
-    <p:sldId xmlns:r="http://schemas.openxmlformats.org/officeDocument/2006/relationships" id="260" r:id="R25b1de847ff241d4"/>
-    <p:sldId xmlns:r="http://schemas.openxmlformats.org/officeDocument/2006/relationships" id="261" r:id="Rcbca33f847b04d0f"/>
+    <p:sldId xmlns:r="http://schemas.openxmlformats.org/officeDocument/2006/relationships" id="256" r:id="Rcc0ce4c34812478b"/>
+    <p:sldId xmlns:r="http://schemas.openxmlformats.org/officeDocument/2006/relationships" id="257" r:id="R5aa19b7e856f4a3d"/>
+    <p:sldId xmlns:r="http://schemas.openxmlformats.org/officeDocument/2006/relationships" id="258" r:id="R8facc10f00874b79"/>
+    <p:sldId xmlns:r="http://schemas.openxmlformats.org/officeDocument/2006/relationships" id="259" r:id="R1d8d91c164374278"/>
+    <p:sldId xmlns:r="http://schemas.openxmlformats.org/officeDocument/2006/relationships" id="260" r:id="R9acecd7355594f44"/>
+    <p:sldId xmlns:r="http://schemas.openxmlformats.org/officeDocument/2006/relationships" id="261" r:id="R746da517ef4c40ce"/>
   </p:sldIdLst>
   <p:sldSz cx="12192000" cy="6858000"/>
   <p:notesSz cx="6858000" cy="9144000"/>
@@ -447,7 +447,7 @@
           <a:lstStyle xmlns:a="http://schemas.openxmlformats.org/drawingml/2006/main"/>
           <a:p xmlns:a="http://schemas.openxmlformats.org/drawingml/2006/main">
             <a:r>
-              <a:t>Teaching focus: CAH-023 adds a vendor translation seam without moving orchestration into the SDK.</a:t>
+              <a:t>Teaching focus: CAH-023 adds a Luna-specific translation seam without moving orchestration into the SDK.</a:t>
             </a:r>
           </a:p>
           <a:p xmlns:a="http://schemas.openxmlformats.org/drawingml/2006/main">
@@ -537,7 +537,7 @@
           <a:lstStyle xmlns:a="http://schemas.openxmlformats.org/drawingml/2006/main"/>
           <a:p xmlns:a="http://schemas.openxmlformats.org/drawingml/2006/main">
             <a:r>
-              <a:t>Walk left to right. The highlighted box is the only CAH-023 responsibility; the evidence branch and tool boundary show what it does not own.</a:t>
+              <a:t>Walk left to right. The highlighted box is the only CAH-023 responsibility; the evidence branch and tool boundary show what it does not own. Luna remains outside the provider-neutral harness port.</a:t>
             </a:r>
           </a:p>
           <a:p xmlns:a="http://schemas.openxmlformats.org/drawingml/2006/main">
@@ -647,7 +647,7 @@
           <a:lstStyle xmlns:a="http://schemas.openxmlformats.org/drawingml/2006/main"/>
           <a:p xmlns:a="http://schemas.openxmlformats.org/drawingml/2006/main">
             <a:r>
-              <a:t>Contrast the two trust boundaries: unsafe process configuration is rejected before SDK import, while the request mapper emits only the reviewed foreground subset.</a:t>
+              <a:t>Contrast the two trust boundaries: the explicit helper admits one local credential into the launched process environment, while only Python consumes it as provider configuration and the request mapper emits the reviewed Luna subset.</a:t>
             </a:r>
           </a:p>
           <a:p xmlns:a="http://schemas.openxmlformats.org/drawingml/2006/main">
@@ -662,6 +662,11 @@
           </a:p>
           <a:p xmlns:a="http://schemas.openxmlformats.org/drawingml/2006/main">
             <a:r>
+              <a:t>- scripts/with-openai-dev-key</a:t>
+            </a:r>
+          </a:p>
+          <a:p xmlns:a="http://schemas.openxmlformats.org/drawingml/2006/main">
+            <a:r>
               <a:t>- src/code_assist_harness/provider/openai_config.py</a:t>
             </a:r>
           </a:p>
@@ -672,22 +677,17 @@
           </a:p>
           <a:p xmlns:a="http://schemas.openxmlformats.org/drawingml/2006/main">
             <a:r>
-              <a:t>- src/code_assist_harness/provider/openai_responses.py:639-680</a:t>
-            </a:r>
-          </a:p>
-          <a:p xmlns:a="http://schemas.openxmlformats.org/drawingml/2006/main">
-            <a:r>
-              <a:t>- https://developers.openai.com/api/docs/guides/streaming-responses</a:t>
-            </a:r>
-          </a:p>
-          <a:p xmlns:a="http://schemas.openxmlformats.org/drawingml/2006/main">
-            <a:r>
-              <a:t>- https://developers.openai.com/api/docs/guides/migrate-to-responses#4-decide-when-to-use-statefulness</a:t>
-            </a:r>
-          </a:p>
-          <a:p xmlns:a="http://schemas.openxmlformats.org/drawingml/2006/main">
-            <a:r>
-              <a:t>- https://developers.openai.com/api/docs/models/gpt-4.1-mini</a:t>
+              <a:t>- src/code_assist_harness/provider/openai_responses.py</a:t>
+            </a:r>
+          </a:p>
+          <a:p xmlns:a="http://schemas.openxmlformats.org/drawingml/2006/main">
+            <a:r>
+              <a:t>- https://developers.openai.com/api/docs/models/gpt-5.6-luna</a:t>
+            </a:r>
+          </a:p>
+          <a:p xmlns:a="http://schemas.openxmlformats.org/drawingml/2006/main">
+            <a:r>
+              <a:t>- https://developers.openai.com/api/docs/guides/latest-model#update-api-and-model-parameters</a:t>
             </a:r>
           </a:p>
         </p:txBody>
@@ -757,7 +757,7 @@
           <a:lstStyle xmlns:a="http://schemas.openxmlformats.org/drawingml/2006/main"/>
           <a:p xmlns:a="http://schemas.openxmlformats.org/drawingml/2006/main">
             <a:r>
-              <a:t>The stream is deliberately smaller than the vendor event universe. Structural events are validated and suppressed; only text progress, usage, completion, or a normalized failure cross the port.</a:t>
+              <a:t>The stream is deliberately smaller than the vendor event universe. An optional opaque reasoning item is validated and suppressed; only text progress, usage, completion, or a normalized failure cross the port.</a:t>
             </a:r>
           </a:p>
           <a:p xmlns:a="http://schemas.openxmlformats.org/drawingml/2006/main">
@@ -772,7 +772,7 @@
           </a:p>
           <a:p xmlns:a="http://schemas.openxmlformats.org/drawingml/2006/main">
             <a:r>
-              <a:t>- src/code_assist_harness/provider/openai_responses.py:444-610</a:t>
+              <a:t>- src/code_assist_harness/provider/openai_responses.py</a:t>
             </a:r>
           </a:p>
           <a:p xmlns:a="http://schemas.openxmlformats.org/drawingml/2006/main">
@@ -872,7 +872,7 @@
           </a:p>
           <a:p xmlns:a="http://schemas.openxmlformats.org/drawingml/2006/main">
             <a:r>
-              <a:t>- src/code_assist_harness/provider/openai_responses.py:303-415</a:t>
+              <a:t>- src/code_assist_harness/provider/openai_responses.py</a:t>
             </a:r>
           </a:p>
           <a:p xmlns:a="http://schemas.openxmlformats.org/drawingml/2006/main">
@@ -882,7 +882,7 @@
           </a:p>
           <a:p xmlns:a="http://schemas.openxmlformats.org/drawingml/2006/main">
             <a:r>
-              <a:t>- tests/provider/test_openai_responses.py:594-797</a:t>
+              <a:t>- tests/provider/test_openai_responses.py</a:t>
             </a:r>
           </a:p>
         </p:txBody>
@@ -973,6 +973,11 @@
           <a:p xmlns:a="http://schemas.openxmlformats.org/drawingml/2006/main">
             <a:r>
               <a:t>- tests/provider/test_openai_config.py</a:t>
+            </a:r>
+          </a:p>
+          <a:p xmlns:a="http://schemas.openxmlformats.org/drawingml/2006/main">
+            <a:r>
+              <a:t>- tests/test_openai_dev_key_script.py</a:t>
             </a:r>
           </a:p>
           <a:p xmlns:a="http://schemas.openxmlformats.org/drawingml/2006/main">
@@ -1060,7 +1065,7 @@
   </p:cSld>
   <p:clrMap bg1="lt1" tx1="dk1" bg2="lt2" tx2="dk2" accent1="accent1" accent2="accent2" accent3="accent3" accent4="accent4" accent5="accent5" accent6="accent6" hlink="hlink" folHlink="folHlink"/>
   <p:sldLayoutIdLst>
-    <p:sldLayoutId xmlns:r="http://schemas.openxmlformats.org/officeDocument/2006/relationships" id="2147483649" r:id="Rd68219904a91455d"/>
+    <p:sldLayoutId xmlns:r="http://schemas.openxmlformats.org/officeDocument/2006/relationships" id="2147483649" r:id="R334936d8325a4bc4"/>
   </p:sldLayoutIdLst>
   <p:txStyles>
     <p:titleStyle>
@@ -1639,6 +1644,7 @@
           <a:lstStyle xmlns:a="http://schemas.openxmlformats.org/drawingml/2006/main"/>
           <a:p xmlns:a="http://schemas.openxmlformats.org/drawingml/2006/main">
             <a:pPr algn="l">
+              <a:buNone/>
               <a:defRPr sz="1800" b="1">
                 <a:solidFill>
                   <a:srgbClr val="3D8DFF"/>
@@ -1695,6 +1701,7 @@
           <a:lstStyle xmlns:a="http://schemas.openxmlformats.org/drawingml/2006/main"/>
           <a:p xmlns:a="http://schemas.openxmlformats.org/drawingml/2006/main">
             <a:pPr algn="l">
+              <a:buNone/>
               <a:defRPr sz="5700" b="0">
                 <a:solidFill>
                   <a:srgbClr val="000000"/>
@@ -1713,11 +1720,12 @@
                 <a:ea typeface="Helvetica Neue"/>
                 <a:cs typeface="Helvetica Neue"/>
               </a:rPr>
-              <a:t>OpenAI enters at</a:t>
-            </a:r>
-          </a:p>
-          <a:p xmlns:a="http://schemas.openxmlformats.org/drawingml/2006/main">
-            <a:pPr algn="l">
+              <a:t>Luna enters at</a:t>
+            </a:r>
+          </a:p>
+          <a:p xmlns:a="http://schemas.openxmlformats.org/drawingml/2006/main">
+            <a:pPr algn="l">
+              <a:buNone/>
               <a:defRPr sz="5700" b="0">
                 <a:solidFill>
                   <a:srgbClr val="000000"/>
@@ -1805,6 +1813,7 @@
           <a:lstStyle xmlns:a="http://schemas.openxmlformats.org/drawingml/2006/main"/>
           <a:p xmlns:a="http://schemas.openxmlformats.org/drawingml/2006/main">
             <a:pPr algn="l">
+              <a:buNone/>
               <a:defRPr sz="2100" b="0">
                 <a:solidFill>
                   <a:srgbClr val="5B6470"/>
@@ -1861,6 +1870,7 @@
           <a:lstStyle xmlns:a="http://schemas.openxmlformats.org/drawingml/2006/main"/>
           <a:p xmlns:a="http://schemas.openxmlformats.org/drawingml/2006/main">
             <a:pPr algn="l">
+              <a:buNone/>
               <a:defRPr sz="1050" b="1">
                 <a:solidFill>
                   <a:srgbClr val="5B6470"/>
@@ -1946,6 +1956,7 @@
           <a:lstStyle xmlns:a="http://schemas.openxmlformats.org/drawingml/2006/main"/>
           <a:p xmlns:a="http://schemas.openxmlformats.org/drawingml/2006/main">
             <a:pPr algn="l">
+              <a:buNone/>
               <a:defRPr sz="3450" b="0">
                 <a:solidFill>
                   <a:srgbClr val="000000"/>
@@ -1964,7 +1975,7 @@
                 <a:ea typeface="Helvetica Neue"/>
                 <a:cs typeface="Helvetica Neue"/>
               </a:rPr>
-              <a:t>CAH-023 translates at the provider edge—nothing more</a:t>
+              <a:t>CAH-023 owns only provider translation</a:t>
             </a:r>
           </a:p>
         </p:txBody>
@@ -2002,6 +2013,7 @@
           <a:lstStyle xmlns:a="http://schemas.openxmlformats.org/drawingml/2006/main"/>
           <a:p xmlns:a="http://schemas.openxmlformats.org/drawingml/2006/main">
             <a:pPr algn="r">
+              <a:buNone/>
               <a:defRPr sz="1050" b="0">
                 <a:solidFill>
                   <a:srgbClr val="5B6470"/>
@@ -2091,6 +2103,7 @@
           <a:lstStyle xmlns:a="http://schemas.openxmlformats.org/drawingml/2006/main"/>
           <a:p xmlns:a="http://schemas.openxmlformats.org/drawingml/2006/main">
             <a:pPr algn="l">
+              <a:buNone/>
               <a:defRPr sz="1200" b="1">
                 <a:solidFill>
                   <a:srgbClr val="5B6470"/>
@@ -2180,6 +2193,7 @@
           <a:lstStyle xmlns:a="http://schemas.openxmlformats.org/drawingml/2006/main"/>
           <a:p xmlns:a="http://schemas.openxmlformats.org/drawingml/2006/main">
             <a:pPr algn="l">
+              <a:buNone/>
               <a:defRPr sz="1200" b="1">
                 <a:solidFill>
                   <a:srgbClr val="5B6470"/>
@@ -2269,6 +2283,7 @@
           <a:lstStyle xmlns:a="http://schemas.openxmlformats.org/drawingml/2006/main"/>
           <a:p xmlns:a="http://schemas.openxmlformats.org/drawingml/2006/main">
             <a:pPr algn="l">
+              <a:buNone/>
               <a:defRPr sz="1200" b="1">
                 <a:solidFill>
                   <a:srgbClr val="5B6470"/>
@@ -2358,6 +2373,7 @@
           <a:lstStyle xmlns:a="http://schemas.openxmlformats.org/drawingml/2006/main"/>
           <a:p xmlns:a="http://schemas.openxmlformats.org/drawingml/2006/main">
             <a:pPr algn="l">
+              <a:buNone/>
               <a:defRPr sz="1200" b="1">
                 <a:solidFill>
                   <a:srgbClr val="5B6470"/>
@@ -2633,6 +2649,7 @@
           <a:lstStyle xmlns:a="http://schemas.openxmlformats.org/drawingml/2006/main"/>
           <a:p xmlns:a="http://schemas.openxmlformats.org/drawingml/2006/main">
             <a:pPr algn="l">
+              <a:buNone/>
               <a:defRPr sz="1350" b="1">
                 <a:solidFill>
                   <a:srgbClr val="000000"/>
@@ -2689,6 +2706,7 @@
           <a:lstStyle xmlns:a="http://schemas.openxmlformats.org/drawingml/2006/main"/>
           <a:p xmlns:a="http://schemas.openxmlformats.org/drawingml/2006/main">
             <a:pPr algn="l">
+              <a:buNone/>
               <a:defRPr sz="1200" b="0">
                 <a:solidFill>
                   <a:srgbClr val="5B6470"/>
@@ -2707,11 +2725,12 @@
                 <a:ea typeface="Helvetica Neue"/>
                 <a:cs typeface="Helvetica Neue"/>
               </a:rPr>
-              <a:t>--provider</a:t>
-            </a:r>
-          </a:p>
-          <a:p xmlns:a="http://schemas.openxmlformats.org/drawingml/2006/main">
-            <a:pPr algn="l">
+              <a:t>provider</a:t>
+            </a:r>
+          </a:p>
+          <a:p xmlns:a="http://schemas.openxmlformats.org/drawingml/2006/main">
+            <a:pPr algn="l">
+              <a:buNone/>
               <a:defRPr sz="1200" b="0">
                 <a:solidFill>
                   <a:srgbClr val="5B6470"/>
@@ -2730,7 +2749,7 @@
                 <a:ea typeface="Helvetica Neue"/>
                 <a:cs typeface="Helvetica Neue"/>
               </a:rPr>
-              <a:t>--model</a:t>
+              <a:t>model</a:t>
             </a:r>
           </a:p>
         </p:txBody>
@@ -2801,6 +2820,7 @@
           <a:lstStyle xmlns:a="http://schemas.openxmlformats.org/drawingml/2006/main"/>
           <a:p xmlns:a="http://schemas.openxmlformats.org/drawingml/2006/main">
             <a:pPr algn="l">
+              <a:buNone/>
               <a:defRPr sz="1350" b="1">
                 <a:solidFill>
                   <a:srgbClr val="000000"/>
@@ -2857,6 +2877,7 @@
           <a:lstStyle xmlns:a="http://schemas.openxmlformats.org/drawingml/2006/main"/>
           <a:p xmlns:a="http://schemas.openxmlformats.org/drawingml/2006/main">
             <a:pPr algn="l">
+              <a:buNone/>
               <a:defRPr sz="1200" b="0">
                 <a:solidFill>
                   <a:srgbClr val="5B6470"/>
@@ -2880,6 +2901,7 @@
           </a:p>
           <a:p xmlns:a="http://schemas.openxmlformats.org/drawingml/2006/main">
             <a:pPr algn="l">
+              <a:buNone/>
               <a:defRPr sz="1200" b="0">
                 <a:solidFill>
                   <a:srgbClr val="5B6470"/>
@@ -2969,6 +2991,7 @@
           <a:lstStyle xmlns:a="http://schemas.openxmlformats.org/drawingml/2006/main"/>
           <a:p xmlns:a="http://schemas.openxmlformats.org/drawingml/2006/main">
             <a:pPr algn="l">
+              <a:buNone/>
               <a:defRPr sz="1350" b="1">
                 <a:solidFill>
                   <a:srgbClr val="000000"/>
@@ -3025,6 +3048,7 @@
           <a:lstStyle xmlns:a="http://schemas.openxmlformats.org/drawingml/2006/main"/>
           <a:p xmlns:a="http://schemas.openxmlformats.org/drawingml/2006/main">
             <a:pPr algn="l">
+              <a:buNone/>
               <a:defRPr sz="1200" b="0">
                 <a:solidFill>
                   <a:srgbClr val="5B6470"/>
@@ -3048,6 +3072,7 @@
           </a:p>
           <a:p xmlns:a="http://schemas.openxmlformats.org/drawingml/2006/main">
             <a:pPr algn="l">
+              <a:buNone/>
               <a:defRPr sz="1200" b="0">
                 <a:solidFill>
                   <a:srgbClr val="5B6470"/>
@@ -3137,6 +3162,7 @@
           <a:lstStyle xmlns:a="http://schemas.openxmlformats.org/drawingml/2006/main"/>
           <a:p xmlns:a="http://schemas.openxmlformats.org/drawingml/2006/main">
             <a:pPr algn="l">
+              <a:buNone/>
               <a:defRPr sz="1350" b="1">
                 <a:solidFill>
                   <a:srgbClr val="000000"/>
@@ -3193,6 +3219,7 @@
           <a:lstStyle xmlns:a="http://schemas.openxmlformats.org/drawingml/2006/main"/>
           <a:p xmlns:a="http://schemas.openxmlformats.org/drawingml/2006/main">
             <a:pPr algn="l">
+              <a:buNone/>
               <a:defRPr sz="1200" b="0">
                 <a:solidFill>
                   <a:srgbClr val="5B6470"/>
@@ -3203,7 +3230,7 @@
               </a:defRPr>
             </a:pPr>
             <a:r>
-              <a:rPr sz="1200" b="0">
+              <a:rPr sz="900" b="0">
                 <a:solidFill>
                   <a:srgbClr val="5B6470"/>
                 </a:solidFill>
@@ -3216,6 +3243,7 @@
           </a:p>
           <a:p xmlns:a="http://schemas.openxmlformats.org/drawingml/2006/main">
             <a:pPr algn="l">
+              <a:buNone/>
               <a:defRPr sz="1200" b="0">
                 <a:solidFill>
                   <a:srgbClr val="5B6470"/>
@@ -3226,7 +3254,7 @@
               </a:defRPr>
             </a:pPr>
             <a:r>
-              <a:rPr sz="1200" b="0">
+              <a:rPr sz="900" b="0">
                 <a:solidFill>
                   <a:srgbClr val="5B6470"/>
                 </a:solidFill>
@@ -3305,6 +3333,7 @@
           <a:lstStyle xmlns:a="http://schemas.openxmlformats.org/drawingml/2006/main"/>
           <a:p xmlns:a="http://schemas.openxmlformats.org/drawingml/2006/main">
             <a:pPr algn="l">
+              <a:buNone/>
               <a:defRPr sz="1350" b="1">
                 <a:solidFill>
                   <a:srgbClr val="125FC7"/>
@@ -3361,6 +3390,7 @@
           <a:lstStyle xmlns:a="http://schemas.openxmlformats.org/drawingml/2006/main"/>
           <a:p xmlns:a="http://schemas.openxmlformats.org/drawingml/2006/main">
             <a:pPr algn="l">
+              <a:buNone/>
               <a:defRPr sz="1200" b="0">
                 <a:solidFill>
                   <a:srgbClr val="5B6470"/>
@@ -3379,11 +3409,12 @@
                 <a:ea typeface="Helvetica Neue"/>
                 <a:cs typeface="Helvetica Neue"/>
               </a:rPr>
-              <a:t>Request + strict</a:t>
-            </a:r>
-          </a:p>
-          <a:p xmlns:a="http://schemas.openxmlformats.org/drawingml/2006/main">
-            <a:pPr algn="l">
+              <a:t>Luna request +</a:t>
+            </a:r>
+          </a:p>
+          <a:p xmlns:a="http://schemas.openxmlformats.org/drawingml/2006/main">
+            <a:pPr algn="l">
+              <a:buNone/>
               <a:defRPr sz="1200" b="0">
                 <a:solidFill>
                   <a:srgbClr val="5B6470"/>
@@ -3402,7 +3433,7 @@
                 <a:ea typeface="Helvetica Neue"/>
                 <a:cs typeface="Helvetica Neue"/>
               </a:rPr>
-              <a:t>stream grammar</a:t>
+              <a:t>strict grammar</a:t>
             </a:r>
           </a:p>
         </p:txBody>
@@ -3473,6 +3504,7 @@
           <a:lstStyle xmlns:a="http://schemas.openxmlformats.org/drawingml/2006/main"/>
           <a:p xmlns:a="http://schemas.openxmlformats.org/drawingml/2006/main">
             <a:pPr algn="l">
+              <a:buNone/>
               <a:defRPr sz="1350" b="1">
                 <a:solidFill>
                   <a:srgbClr val="000000"/>
@@ -3483,7 +3515,7 @@
               </a:defRPr>
             </a:pPr>
             <a:r>
-              <a:rPr sz="1350" b="1">
+              <a:rPr sz="900" b="1">
                 <a:solidFill>
                   <a:srgbClr val="000000"/>
                 </a:solidFill>
@@ -3491,7 +3523,8 @@
                 <a:ea typeface="Helvetica Neue"/>
                 <a:cs typeface="Helvetica Neue"/>
               </a:rPr>
-              <a:t>Responses</a:t>
+              <a:t>Responses
+API</a:t>
             </a:r>
           </a:p>
         </p:txBody>
@@ -3529,6 +3562,7 @@
           <a:lstStyle xmlns:a="http://schemas.openxmlformats.org/drawingml/2006/main"/>
           <a:p xmlns:a="http://schemas.openxmlformats.org/drawingml/2006/main">
             <a:pPr algn="l">
+              <a:buNone/>
               <a:defRPr sz="1200" b="0">
                 <a:solidFill>
                   <a:srgbClr val="5B6470"/>
@@ -3547,7 +3581,7 @@
                 <a:ea typeface="Helvetica Neue"/>
                 <a:cs typeface="Helvetica Neue"/>
               </a:rPr>
-              <a:t>OpenAI API</a:t>
+              <a:t>Luna model</a:t>
             </a:r>
           </a:p>
         </p:txBody>
@@ -3618,6 +3652,7 @@
           <a:lstStyle xmlns:a="http://schemas.openxmlformats.org/drawingml/2006/main"/>
           <a:p xmlns:a="http://schemas.openxmlformats.org/drawingml/2006/main">
             <a:pPr algn="l">
+              <a:buNone/>
               <a:defRPr sz="1200" b="1">
                 <a:solidFill>
                   <a:srgbClr val="000000"/>
@@ -3674,6 +3709,7 @@
           <a:lstStyle xmlns:a="http://schemas.openxmlformats.org/drawingml/2006/main"/>
           <a:p xmlns:a="http://schemas.openxmlformats.org/drawingml/2006/main">
             <a:pPr algn="l">
+              <a:buNone/>
               <a:defRPr sz="1200" b="0">
                 <a:solidFill>
                   <a:srgbClr val="5B6470"/>
@@ -3761,6 +3797,7 @@
           <a:lstStyle xmlns:a="http://schemas.openxmlformats.org/drawingml/2006/main"/>
           <a:p xmlns:a="http://schemas.openxmlformats.org/drawingml/2006/main">
             <a:pPr algn="ctr">
+              <a:buNone/>
               <a:defRPr sz="1200" b="1">
                 <a:solidFill>
                   <a:srgbClr val="3D8DFF"/>
@@ -3817,6 +3854,7 @@
           <a:lstStyle xmlns:a="http://schemas.openxmlformats.org/drawingml/2006/main"/>
           <a:p xmlns:a="http://schemas.openxmlformats.org/drawingml/2006/main">
             <a:pPr algn="r">
+              <a:buNone/>
               <a:defRPr sz="1425" b="0">
                 <a:solidFill>
                   <a:srgbClr val="5B6470"/>
@@ -3902,6 +3940,7 @@
           <a:lstStyle xmlns:a="http://schemas.openxmlformats.org/drawingml/2006/main"/>
           <a:p xmlns:a="http://schemas.openxmlformats.org/drawingml/2006/main">
             <a:pPr algn="l">
+              <a:buNone/>
               <a:defRPr sz="3450" b="0">
                 <a:solidFill>
                   <a:srgbClr val="000000"/>
@@ -3958,6 +3997,7 @@
           <a:lstStyle xmlns:a="http://schemas.openxmlformats.org/drawingml/2006/main"/>
           <a:p xmlns:a="http://schemas.openxmlformats.org/drawingml/2006/main">
             <a:pPr algn="r">
+              <a:buNone/>
               <a:defRPr sz="1050" b="0">
                 <a:solidFill>
                   <a:srgbClr val="5B6470"/>
@@ -4107,6 +4147,7 @@
           <a:lstStyle xmlns:a="http://schemas.openxmlformats.org/drawingml/2006/main"/>
           <a:p xmlns:a="http://schemas.openxmlformats.org/drawingml/2006/main">
             <a:pPr algn="l">
+              <a:buNone/>
               <a:defRPr sz="2100" b="1">
                 <a:solidFill>
                   <a:srgbClr val="000000"/>
@@ -4163,6 +4204,7 @@
           <a:lstStyle xmlns:a="http://schemas.openxmlformats.org/drawingml/2006/main"/>
           <a:p xmlns:a="http://schemas.openxmlformats.org/drawingml/2006/main">
             <a:pPr algn="l">
+              <a:buNone/>
               <a:defRPr sz="1500" b="0">
                 <a:solidFill>
                   <a:srgbClr val="5B6470"/>
@@ -4191,6 +4233,7 @@
           </a:p>
           <a:p xmlns:a="http://schemas.openxmlformats.org/drawingml/2006/main">
             <a:pPr algn="l">
+              <a:buNone/>
               <a:defRPr sz="1500" b="0">
                 <a:solidFill>
                   <a:srgbClr val="5B6470"/>
@@ -4209,7 +4252,7 @@
                 <a:ea typeface="Helvetica Neue"/>
                 <a:cs typeface="Helvetica Neue"/>
               </a:rPr>
-              <a:t>OpenAI requires an explicit provider + exact model snapshot.</a:t>
+              <a:t>OpenAI requires explicit provider + gpt-5.6-luna.</a:t>
             </a:r>
           </a:p>
           <a:p xmlns:a="http://schemas.openxmlformats.org/drawingml/2006/main">
@@ -4219,6 +4262,7 @@
           </a:p>
           <a:p xmlns:a="http://schemas.openxmlformats.org/drawingml/2006/main">
             <a:pPr algn="l">
+              <a:buNone/>
               <a:defRPr sz="1500" b="0">
                 <a:solidFill>
                   <a:srgbClr val="5B6470"/>
@@ -4237,7 +4281,7 @@
                 <a:ea typeface="Helvetica Neue"/>
                 <a:cs typeface="Helvetica Neue"/>
               </a:rPr>
-              <a:t>Only OPENAI_API_KEY is accepted; every other OPENAI_* setting is rejected.</a:t>
+              <a:t>with-openai-dev-key reads only ignored dev.env.</a:t>
             </a:r>
           </a:p>
           <a:p xmlns:a="http://schemas.openxmlformats.org/drawingml/2006/main">
@@ -4247,6 +4291,7 @@
           </a:p>
           <a:p xmlns:a="http://schemas.openxmlformats.org/drawingml/2006/main">
             <a:pPr algn="l">
+              <a:buNone/>
               <a:defRPr sz="1500" b="0">
                 <a:solidFill>
                   <a:srgbClr val="5B6470"/>
@@ -4303,6 +4348,7 @@
           <a:lstStyle xmlns:a="http://schemas.openxmlformats.org/drawingml/2006/main"/>
           <a:p xmlns:a="http://schemas.openxmlformats.org/drawingml/2006/main">
             <a:pPr algn="l">
+              <a:buNone/>
               <a:defRPr sz="2100" b="1">
                 <a:solidFill>
                   <a:srgbClr val="000000"/>
@@ -4359,6 +4405,7 @@
           <a:lstStyle xmlns:a="http://schemas.openxmlformats.org/drawingml/2006/main"/>
           <a:p xmlns:a="http://schemas.openxmlformats.org/drawingml/2006/main">
             <a:pPr algn="l">
+              <a:buNone/>
               <a:defRPr sz="1500" b="0">
                 <a:solidFill>
                   <a:srgbClr val="5B6470"/>
@@ -4387,6 +4434,7 @@
           </a:p>
           <a:p xmlns:a="http://schemas.openxmlformats.org/drawingml/2006/main">
             <a:pPr algn="l">
+              <a:buNone/>
               <a:defRPr sz="1500" b="0">
                 <a:solidFill>
                   <a:srgbClr val="5B6470"/>
@@ -4405,7 +4453,7 @@
                 <a:ea typeface="Helvetica Neue"/>
                 <a:cs typeface="Helvetica Neue"/>
               </a:rPr>
-              <a:t>Ordered repository guidance → JSON instructions</a:t>
+              <a:t>reasoning = none · context = current_turn</a:t>
             </a:r>
           </a:p>
           <a:p xmlns:a="http://schemas.openxmlformats.org/drawingml/2006/main">
@@ -4415,6 +4463,7 @@
           </a:p>
           <a:p xmlns:a="http://schemas.openxmlformats.org/drawingml/2006/main">
             <a:pPr algn="l">
+              <a:buNone/>
               <a:defRPr sz="1500" b="0">
                 <a:solidFill>
                   <a:srgbClr val="5B6470"/>
@@ -4433,35 +4482,36 @@
                 <a:ea typeface="Helvetica Neue"/>
                 <a:cs typeface="Helvetica Neue"/>
               </a:rPr>
+              <a:t>max_output_tokens = 8192</a:t>
+            </a:r>
+          </a:p>
+          <a:p xmlns:a="http://schemas.openxmlformats.org/drawingml/2006/main">
+            <a:r>
+              <a:t/>
+            </a:r>
+          </a:p>
+          <a:p xmlns:a="http://schemas.openxmlformats.org/drawingml/2006/main">
+            <a:pPr algn="l">
+              <a:buNone/>
+              <a:defRPr sz="1500" b="0">
+                <a:solidFill>
+                  <a:srgbClr val="5B6470"/>
+                </a:solidFill>
+                <a:latin typeface="Helvetica Neue"/>
+                <a:ea typeface="Helvetica Neue"/>
+                <a:cs typeface="Helvetica Neue"/>
+              </a:defRPr>
+            </a:pPr>
+            <a:r>
+              <a:rPr sz="1500" b="0">
+                <a:solidFill>
+                  <a:srgbClr val="5B6470"/>
+                </a:solidFill>
+                <a:latin typeface="Helvetica Neue"/>
+                <a:ea typeface="Helvetica Neue"/>
+                <a:cs typeface="Helvetica Neue"/>
+              </a:rPr>
               <a:t>stream = true · background = false · store = false</a:t>
-            </a:r>
-          </a:p>
-          <a:p xmlns:a="http://schemas.openxmlformats.org/drawingml/2006/main">
-            <a:r>
-              <a:t/>
-            </a:r>
-          </a:p>
-          <a:p xmlns:a="http://schemas.openxmlformats.org/drawingml/2006/main">
-            <a:pPr algn="l">
-              <a:defRPr sz="1500" b="0">
-                <a:solidFill>
-                  <a:srgbClr val="5B6470"/>
-                </a:solidFill>
-                <a:latin typeface="Helvetica Neue"/>
-                <a:ea typeface="Helvetica Neue"/>
-                <a:cs typeface="Helvetica Neue"/>
-              </a:defRPr>
-            </a:pPr>
-            <a:r>
-              <a:rPr sz="1500" b="0">
-                <a:solidFill>
-                  <a:srgbClr val="5B6470"/>
-                </a:solidFill>
-                <a:latin typeface="Helvetica Neue"/>
-                <a:ea typeface="Helvetica Neue"/>
-                <a:cs typeface="Helvetica Neue"/>
-              </a:rPr>
-              <a:t>Retries = 0 · proxy env off · redirects off</a:t>
             </a:r>
           </a:p>
         </p:txBody>
@@ -4530,6 +4580,7 @@
           <a:lstStyle xmlns:a="http://schemas.openxmlformats.org/drawingml/2006/main"/>
           <a:p xmlns:a="http://schemas.openxmlformats.org/drawingml/2006/main">
             <a:pPr algn="ctr">
+              <a:buNone/>
               <a:defRPr sz="1350" b="1">
                 <a:solidFill>
                   <a:srgbClr val="000000"/>
@@ -4548,7 +4599,7 @@
                 <a:ea typeface="Helvetica Neue"/>
                 <a:cs typeface="Helvetica Neue"/>
               </a:rPr>
-              <a:t>Boundary rule: credentials configure the adapter; they never enter provider-neutral requests or events.</a:t>
+              <a:t>Boundary rule: dev.env enters the launched environment; only Python consumes it as provider config.</a:t>
             </a:r>
           </a:p>
         </p:txBody>
@@ -4615,6 +4666,7 @@
           <a:lstStyle xmlns:a="http://schemas.openxmlformats.org/drawingml/2006/main"/>
           <a:p xmlns:a="http://schemas.openxmlformats.org/drawingml/2006/main">
             <a:pPr algn="l">
+              <a:buNone/>
               <a:defRPr sz="3450" b="0">
                 <a:solidFill>
                   <a:srgbClr val="000000"/>
@@ -4633,7 +4685,7 @@
                 <a:ea typeface="Helvetica Neue"/>
                 <a:cs typeface="Helvetica Neue"/>
               </a:rPr>
-              <a:t>A narrow stream grammar becomes four domain events</a:t>
+              <a:t>A Luna stream becomes four domain events</a:t>
             </a:r>
           </a:p>
         </p:txBody>
@@ -4671,6 +4723,7 @@
           <a:lstStyle xmlns:a="http://schemas.openxmlformats.org/drawingml/2006/main"/>
           <a:p xmlns:a="http://schemas.openxmlformats.org/drawingml/2006/main">
             <a:pPr algn="r">
+              <a:buNone/>
               <a:defRPr sz="1050" b="0">
                 <a:solidFill>
                   <a:srgbClr val="5B6470"/>
@@ -4851,6 +4904,7 @@
           <a:lstStyle xmlns:a="http://schemas.openxmlformats.org/drawingml/2006/main"/>
           <a:p xmlns:a="http://schemas.openxmlformats.org/drawingml/2006/main">
             <a:pPr algn="l">
+              <a:buNone/>
               <a:defRPr sz="1200" b="1">
                 <a:solidFill>
                   <a:srgbClr val="5B6470"/>
@@ -4907,6 +4961,7 @@
           <a:lstStyle xmlns:a="http://schemas.openxmlformats.org/drawingml/2006/main"/>
           <a:p xmlns:a="http://schemas.openxmlformats.org/drawingml/2006/main">
             <a:pPr algn="l">
+              <a:buNone/>
               <a:defRPr sz="1800" b="1">
                 <a:solidFill>
                   <a:srgbClr val="000000"/>
@@ -4963,6 +5018,7 @@
           <a:lstStyle xmlns:a="http://schemas.openxmlformats.org/drawingml/2006/main"/>
           <a:p xmlns:a="http://schemas.openxmlformats.org/drawingml/2006/main">
             <a:pPr algn="l">
+              <a:buNone/>
               <a:defRPr sz="1350" b="0">
                 <a:solidFill>
                   <a:srgbClr val="5B6470"/>
@@ -4986,6 +5042,7 @@
           </a:p>
           <a:p xmlns:a="http://schemas.openxmlformats.org/drawingml/2006/main">
             <a:pPr algn="l">
+              <a:buNone/>
               <a:defRPr sz="1350" b="0">
                 <a:solidFill>
                   <a:srgbClr val="5B6470"/>
@@ -5042,6 +5099,7 @@
           <a:lstStyle xmlns:a="http://schemas.openxmlformats.org/drawingml/2006/main"/>
           <a:p xmlns:a="http://schemas.openxmlformats.org/drawingml/2006/main">
             <a:pPr algn="l">
+              <a:buNone/>
               <a:defRPr sz="1200" b="1">
                 <a:solidFill>
                   <a:srgbClr val="5B6470"/>
@@ -5060,7 +5118,7 @@
                 <a:ea typeface="Helvetica Neue"/>
                 <a:cs typeface="Helvetica Neue"/>
               </a:rPr>
-              <a:t>02 · ONE TEXT ITEM</a:t>
+              <a:t>02 · OUTPUT ITEMS</a:t>
             </a:r>
           </a:p>
         </p:txBody>
@@ -5098,6 +5156,7 @@
           <a:lstStyle xmlns:a="http://schemas.openxmlformats.org/drawingml/2006/main"/>
           <a:p xmlns:a="http://schemas.openxmlformats.org/drawingml/2006/main">
             <a:pPr algn="l">
+              <a:buNone/>
               <a:defRPr sz="1800" b="1">
                 <a:solidFill>
                   <a:srgbClr val="000000"/>
@@ -5116,7 +5175,7 @@
                 <a:ea typeface="Helvetica Neue"/>
                 <a:cs typeface="Helvetica Neue"/>
               </a:rPr>
-              <a:t>item.added → delta+ → text.done</a:t>
+              <a:t>[reasoning] → message → delta+</a:t>
             </a:r>
           </a:p>
         </p:txBody>
@@ -5154,6 +5213,7 @@
           <a:lstStyle xmlns:a="http://schemas.openxmlformats.org/drawingml/2006/main"/>
           <a:p xmlns:a="http://schemas.openxmlformats.org/drawingml/2006/main">
             <a:pPr algn="l">
+              <a:buNone/>
               <a:defRPr sz="1350" b="0">
                 <a:solidFill>
                   <a:srgbClr val="5B6470"/>
@@ -5172,11 +5232,12 @@
                 <a:ea typeface="Helvetica Neue"/>
                 <a:cs typeface="Helvetica Neue"/>
               </a:rPr>
-              <a:t>Emit ProviderTextDelta.</a:t>
-            </a:r>
-          </a:p>
-          <a:p xmlns:a="http://schemas.openxmlformats.org/drawingml/2006/main">
-            <a:pPr algn="l">
+              <a:t>Opaque reasoning is optional.</a:t>
+            </a:r>
+          </a:p>
+          <a:p xmlns:a="http://schemas.openxmlformats.org/drawingml/2006/main">
+            <a:pPr algn="l">
+              <a:buNone/>
               <a:defRPr sz="1350" b="0">
                 <a:solidFill>
                   <a:srgbClr val="5B6470"/>
@@ -5195,7 +5256,7 @@
                 <a:ea typeface="Helvetica Neue"/>
                 <a:cs typeface="Helvetica Neue"/>
               </a:rPr>
-              <a:t>Rebuilt text must match done text.</a:t>
+              <a:t>Emit only ProviderTextDelta.</a:t>
             </a:r>
           </a:p>
         </p:txBody>
@@ -5233,6 +5294,7 @@
           <a:lstStyle xmlns:a="http://schemas.openxmlformats.org/drawingml/2006/main"/>
           <a:p xmlns:a="http://schemas.openxmlformats.org/drawingml/2006/main">
             <a:pPr algn="l">
+              <a:buNone/>
               <a:defRPr sz="1200" b="1">
                 <a:solidFill>
                   <a:srgbClr val="3D8DFF"/>
@@ -5289,6 +5351,7 @@
           <a:lstStyle xmlns:a="http://schemas.openxmlformats.org/drawingml/2006/main"/>
           <a:p xmlns:a="http://schemas.openxmlformats.org/drawingml/2006/main">
             <a:pPr algn="l">
+              <a:buNone/>
               <a:defRPr sz="1800" b="1">
                 <a:solidFill>
                   <a:srgbClr val="000000"/>
@@ -5307,7 +5370,8 @@
                 <a:ea typeface="Helvetica Neue"/>
                 <a:cs typeface="Helvetica Neue"/>
               </a:rPr>
-              <a:t>part.done → item.done → completed</a:t>
+              <a:t>text.done → part.done → item.done
+→ response.completed</a:t>
             </a:r>
           </a:p>
         </p:txBody>
@@ -5345,6 +5409,7 @@
           <a:lstStyle xmlns:a="http://schemas.openxmlformats.org/drawingml/2006/main"/>
           <a:p xmlns:a="http://schemas.openxmlformats.org/drawingml/2006/main">
             <a:pPr algn="l">
+              <a:buNone/>
               <a:defRPr sz="1350" b="0">
                 <a:solidFill>
                   <a:srgbClr val="5B6470"/>
@@ -5363,11 +5428,12 @@
                 <a:ea typeface="Helvetica Neue"/>
                 <a:cs typeface="Helvetica Neue"/>
               </a:rPr>
-              <a:t>Verify IDs, model, output, usage.</a:t>
-            </a:r>
-          </a:p>
-          <a:p xmlns:a="http://schemas.openxmlformats.org/drawingml/2006/main">
-            <a:pPr algn="l">
+              <a:t>Emit ProviderTextCompleted.</a:t>
+            </a:r>
+          </a:p>
+          <a:p xmlns:a="http://schemas.openxmlformats.org/drawingml/2006/main">
+            <a:pPr algn="l">
+              <a:buNone/>
               <a:defRPr sz="1350" b="0">
                 <a:solidFill>
                   <a:srgbClr val="5B6470"/>
@@ -5386,7 +5452,7 @@
                 <a:ea typeface="Helvetica Neue"/>
                 <a:cs typeface="Helvetica Neue"/>
               </a:rPr>
-              <a:t>Emit usage + ProviderCompleted.</a:t>
+              <a:t>ProviderUsageReported → ProviderCompleted.</a:t>
             </a:r>
           </a:p>
         </p:txBody>
@@ -5457,6 +5523,7 @@
           <a:lstStyle xmlns:a="http://schemas.openxmlformats.org/drawingml/2006/main"/>
           <a:p xmlns:a="http://schemas.openxmlformats.org/drawingml/2006/main">
             <a:pPr algn="l">
+              <a:buNone/>
               <a:defRPr sz="1350" b="1">
                 <a:solidFill>
                   <a:srgbClr val="000000"/>
@@ -5475,7 +5542,7 @@
                 <a:ea typeface="Helvetica Neue"/>
                 <a:cs typeface="Helvetica Neue"/>
               </a:rPr>
-              <a:t>Skipped step, wrong ID, mismatched text, unsupported event, or premature EOF</a:t>
+              <a:t>Reasoning text · wrong ID · text mismatch · unsupported event · EOF</a:t>
             </a:r>
           </a:p>
         </p:txBody>
@@ -5513,6 +5580,7 @@
           <a:lstStyle xmlns:a="http://schemas.openxmlformats.org/drawingml/2006/main"/>
           <a:p xmlns:a="http://schemas.openxmlformats.org/drawingml/2006/main">
             <a:pPr algn="r">
+              <a:buNone/>
               <a:defRPr sz="1350" b="1">
                 <a:solidFill>
                   <a:srgbClr val="125FC7"/>
@@ -5536,6 +5604,7 @@
           </a:p>
           <a:p xmlns:a="http://schemas.openxmlformats.org/drawingml/2006/main">
             <a:pPr algn="r">
+              <a:buNone/>
               <a:defRPr sz="1350" b="1">
                 <a:solidFill>
                   <a:srgbClr val="125FC7"/>
@@ -5592,6 +5661,7 @@
           <a:lstStyle xmlns:a="http://schemas.openxmlformats.org/drawingml/2006/main"/>
           <a:p xmlns:a="http://schemas.openxmlformats.org/drawingml/2006/main">
             <a:pPr algn="l">
+              <a:buNone/>
               <a:defRPr sz="1200" b="0">
                 <a:solidFill>
                   <a:srgbClr val="5B6470"/>
@@ -5610,7 +5680,7 @@
                 <a:ea typeface="Helvetica Neue"/>
                 <a:cs typeface="Helvetica Neue"/>
               </a:rPr>
-              <a:t>The SDK event union never leaks into the harness core.</a:t>
+              <a:t>Reasoning data and SDK events stay inside the adapter.</a:t>
             </a:r>
           </a:p>
         </p:txBody>
@@ -5677,6 +5747,7 @@
           <a:lstStyle xmlns:a="http://schemas.openxmlformats.org/drawingml/2006/main"/>
           <a:p xmlns:a="http://schemas.openxmlformats.org/drawingml/2006/main">
             <a:pPr algn="l">
+              <a:buNone/>
               <a:defRPr sz="3450" b="0">
                 <a:solidFill>
                   <a:srgbClr val="000000"/>
@@ -5695,7 +5766,7 @@
                 <a:ea typeface="Helvetica Neue"/>
                 <a:cs typeface="Helvetica Neue"/>
               </a:rPr>
-              <a:t>One cleanup owner decides when a terminal can escape</a:t>
+              <a:t>Cleanup settles before a terminal escapes</a:t>
             </a:r>
           </a:p>
         </p:txBody>
@@ -5733,6 +5804,7 @@
           <a:lstStyle xmlns:a="http://schemas.openxmlformats.org/drawingml/2006/main"/>
           <a:p xmlns:a="http://schemas.openxmlformats.org/drawingml/2006/main">
             <a:pPr algn="r">
+              <a:buNone/>
               <a:defRPr sz="1050" b="0">
                 <a:solidFill>
                   <a:srgbClr val="5B6470"/>
@@ -5789,6 +5861,7 @@
           <a:lstStyle xmlns:a="http://schemas.openxmlformats.org/drawingml/2006/main"/>
           <a:p xmlns:a="http://schemas.openxmlformats.org/drawingml/2006/main">
             <a:pPr algn="l">
+              <a:buNone/>
               <a:defRPr sz="1650" b="0">
                 <a:solidFill>
                   <a:srgbClr val="5B6470"/>
@@ -5876,6 +5949,7 @@
           <a:lstStyle xmlns:a="http://schemas.openxmlformats.org/drawingml/2006/main"/>
           <a:p xmlns:a="http://schemas.openxmlformats.org/drawingml/2006/main">
             <a:pPr algn="ctr">
+              <a:buNone/>
               <a:defRPr sz="2100" b="1">
                 <a:solidFill>
                   <a:srgbClr val="125FC7"/>
@@ -5965,6 +6039,7 @@
           <a:lstStyle xmlns:a="http://schemas.openxmlformats.org/drawingml/2006/main"/>
           <a:p xmlns:a="http://schemas.openxmlformats.org/drawingml/2006/main">
             <a:pPr algn="l">
+              <a:buNone/>
               <a:defRPr sz="2100" b="1">
                 <a:solidFill>
                   <a:srgbClr val="000000"/>
@@ -6021,6 +6096,7 @@
           <a:lstStyle xmlns:a="http://schemas.openxmlformats.org/drawingml/2006/main"/>
           <a:p xmlns:a="http://schemas.openxmlformats.org/drawingml/2006/main">
             <a:pPr algn="l">
+              <a:buNone/>
               <a:defRPr sz="1500" b="0">
                 <a:solidFill>
                   <a:srgbClr val="5B6470"/>
@@ -6049,6 +6125,7 @@
           </a:p>
           <a:p xmlns:a="http://schemas.openxmlformats.org/drawingml/2006/main">
             <a:pPr algn="l">
+              <a:buNone/>
               <a:defRPr sz="1500" b="0">
                 <a:solidFill>
                   <a:srgbClr val="5B6470"/>
@@ -6077,6 +6154,7 @@
           </a:p>
           <a:p xmlns:a="http://schemas.openxmlformats.org/drawingml/2006/main">
             <a:pPr algn="l">
+              <a:buNone/>
               <a:defRPr sz="1500" b="0">
                 <a:solidFill>
                   <a:srgbClr val="5B6470"/>
@@ -6166,6 +6244,7 @@
           <a:lstStyle xmlns:a="http://schemas.openxmlformats.org/drawingml/2006/main"/>
           <a:p xmlns:a="http://schemas.openxmlformats.org/drawingml/2006/main">
             <a:pPr algn="l">
+              <a:buNone/>
               <a:defRPr sz="2100" b="1">
                 <a:solidFill>
                   <a:srgbClr val="000000"/>
@@ -6222,6 +6301,7 @@
           <a:lstStyle xmlns:a="http://schemas.openxmlformats.org/drawingml/2006/main"/>
           <a:p xmlns:a="http://schemas.openxmlformats.org/drawingml/2006/main">
             <a:pPr algn="l">
+              <a:buNone/>
               <a:defRPr sz="1500" b="0">
                 <a:solidFill>
                   <a:srgbClr val="5B6470"/>
@@ -6250,6 +6330,7 @@
           </a:p>
           <a:p xmlns:a="http://schemas.openxmlformats.org/drawingml/2006/main">
             <a:pPr algn="l">
+              <a:buNone/>
               <a:defRPr sz="1500" b="0">
                 <a:solidFill>
                   <a:srgbClr val="5B6470"/>
@@ -6278,6 +6359,7 @@
           </a:p>
           <a:p xmlns:a="http://schemas.openxmlformats.org/drawingml/2006/main">
             <a:pPr algn="l">
+              <a:buNone/>
               <a:defRPr sz="1500" b="0">
                 <a:solidFill>
                   <a:srgbClr val="5B6470"/>
@@ -6334,6 +6416,7 @@
           <a:lstStyle xmlns:a="http://schemas.openxmlformats.org/drawingml/2006/main"/>
           <a:p xmlns:a="http://schemas.openxmlformats.org/drawingml/2006/main">
             <a:pPr algn="ctr">
+              <a:buNone/>
               <a:defRPr sz="1350" b="1">
                 <a:solidFill>
                   <a:srgbClr val="000000"/>
@@ -6419,6 +6502,7 @@
           <a:lstStyle xmlns:a="http://schemas.openxmlformats.org/drawingml/2006/main"/>
           <a:p xmlns:a="http://schemas.openxmlformats.org/drawingml/2006/main">
             <a:pPr algn="l">
+              <a:buNone/>
               <a:defRPr sz="3450" b="0">
                 <a:solidFill>
                   <a:srgbClr val="000000"/>
@@ -6437,7 +6521,7 @@
                 <a:ea typeface="Helvetica Neue"/>
                 <a:cs typeface="Helvetica Neue"/>
               </a:rPr>
-              <a:t>Deterministic evidence makes the boundary teachable</a:t>
+              <a:t>Deterministic evidence teaches the boundary</a:t>
             </a:r>
           </a:p>
         </p:txBody>
@@ -6475,6 +6559,7 @@
           <a:lstStyle xmlns:a="http://schemas.openxmlformats.org/drawingml/2006/main"/>
           <a:p xmlns:a="http://schemas.openxmlformats.org/drawingml/2006/main">
             <a:pPr algn="r">
+              <a:buNone/>
               <a:defRPr sz="1050" b="0">
                 <a:solidFill>
                   <a:srgbClr val="5B6470"/>
@@ -6531,6 +6616,7 @@
           <a:lstStyle xmlns:a="http://schemas.openxmlformats.org/drawingml/2006/main"/>
           <a:p xmlns:a="http://schemas.openxmlformats.org/drawingml/2006/main">
             <a:pPr algn="l">
+              <a:buNone/>
               <a:defRPr sz="1200" b="1">
                 <a:solidFill>
                   <a:srgbClr val="3D8DFF"/>
@@ -6587,6 +6673,7 @@
           <a:lstStyle xmlns:a="http://schemas.openxmlformats.org/drawingml/2006/main"/>
           <a:p xmlns:a="http://schemas.openxmlformats.org/drawingml/2006/main">
             <a:pPr algn="l">
+              <a:buNone/>
               <a:defRPr sz="2100" b="1">
                 <a:solidFill>
                   <a:srgbClr val="000000"/>
@@ -6605,7 +6692,7 @@
                 <a:ea typeface="Helvetica Neue"/>
                 <a:cs typeface="Helvetica Neue"/>
               </a:rPr>
-              <a:t>Point to the owner of stream grammar, terminal selection, limits, transcripts, and future tool approval.</a:t>
+              <a:t>Name who owns dev.env admission, stream grammar, terminals, limits, transcripts, and future tool approval.</a:t>
             </a:r>
           </a:p>
         </p:txBody>
@@ -6676,6 +6763,7 @@
           <a:lstStyle xmlns:a="http://schemas.openxmlformats.org/drawingml/2006/main"/>
           <a:p xmlns:a="http://schemas.openxmlformats.org/drawingml/2006/main">
             <a:pPr algn="l">
+              <a:buNone/>
               <a:defRPr sz="4800" b="1">
                 <a:solidFill>
                   <a:srgbClr val="3D8DFF"/>
@@ -6694,7 +6782,7 @@
                 <a:ea typeface="Helvetica Neue"/>
                 <a:cs typeface="Helvetica Neue"/>
               </a:rPr>
-              <a:t>78</a:t>
+              <a:t>92</a:t>
             </a:r>
           </a:p>
         </p:txBody>
@@ -6732,6 +6820,7 @@
           <a:lstStyle xmlns:a="http://schemas.openxmlformats.org/drawingml/2006/main"/>
           <a:p xmlns:a="http://schemas.openxmlformats.org/drawingml/2006/main">
             <a:pPr algn="l">
+              <a:buNone/>
               <a:defRPr sz="1800" b="1">
                 <a:solidFill>
                   <a:srgbClr val="000000"/>
@@ -6788,6 +6877,7 @@
           <a:lstStyle xmlns:a="http://schemas.openxmlformats.org/drawingml/2006/main"/>
           <a:p xmlns:a="http://schemas.openxmlformats.org/drawingml/2006/main">
             <a:pPr algn="l">
+              <a:buNone/>
               <a:defRPr sz="1275" b="0">
                 <a:solidFill>
                   <a:srgbClr val="5B6470"/>
@@ -6806,7 +6896,7 @@
                 <a:ea typeface="Helvetica Neue"/>
                 <a:cs typeface="Helvetica Neue"/>
               </a:rPr>
-              <a:t>Success, malformed order, wrong IDs, SDK failures, cleanup, and races.</a:t>
+              <a:t>Message-only + opaque reasoning, malformed streams, cleanup, races.</a:t>
             </a:r>
           </a:p>
         </p:txBody>
@@ -6877,6 +6967,7 @@
           <a:lstStyle xmlns:a="http://schemas.openxmlformats.org/drawingml/2006/main"/>
           <a:p xmlns:a="http://schemas.openxmlformats.org/drawingml/2006/main">
             <a:pPr algn="l">
+              <a:buNone/>
               <a:defRPr sz="4800" b="1">
                 <a:solidFill>
                   <a:srgbClr val="3D8DFF"/>
@@ -6933,6 +7024,7 @@
           <a:lstStyle xmlns:a="http://schemas.openxmlformats.org/drawingml/2006/main"/>
           <a:p xmlns:a="http://schemas.openxmlformats.org/drawingml/2006/main">
             <a:pPr algn="l">
+              <a:buNone/>
               <a:defRPr sz="1800" b="1">
                 <a:solidFill>
                   <a:srgbClr val="000000"/>
@@ -6989,6 +7081,7 @@
           <a:lstStyle xmlns:a="http://schemas.openxmlformats.org/drawingml/2006/main"/>
           <a:p xmlns:a="http://schemas.openxmlformats.org/drawingml/2006/main">
             <a:pPr algn="l">
+              <a:buNone/>
               <a:defRPr sz="1275" b="0">
                 <a:solidFill>
                   <a:srgbClr val="5B6470"/>
@@ -7078,6 +7171,7 @@
           <a:lstStyle xmlns:a="http://schemas.openxmlformats.org/drawingml/2006/main"/>
           <a:p xmlns:a="http://schemas.openxmlformats.org/drawingml/2006/main">
             <a:pPr algn="l">
+              <a:buNone/>
               <a:defRPr sz="4800" b="1">
                 <a:solidFill>
                   <a:srgbClr val="3D8DFF"/>
@@ -7134,6 +7228,7 @@
           <a:lstStyle xmlns:a="http://schemas.openxmlformats.org/drawingml/2006/main"/>
           <a:p xmlns:a="http://schemas.openxmlformats.org/drawingml/2006/main">
             <a:pPr algn="l">
+              <a:buNone/>
               <a:defRPr sz="1800" b="1">
                 <a:solidFill>
                   <a:srgbClr val="000000"/>
@@ -7190,6 +7285,7 @@
           <a:lstStyle xmlns:a="http://schemas.openxmlformats.org/drawingml/2006/main"/>
           <a:p xmlns:a="http://schemas.openxmlformats.org/drawingml/2006/main">
             <a:pPr algn="l">
+              <a:buNone/>
               <a:defRPr sz="1275" b="0">
                 <a:solidFill>
                   <a:srgbClr val="5B6470"/>
@@ -7246,6 +7342,7 @@
           <a:lstStyle xmlns:a="http://schemas.openxmlformats.org/drawingml/2006/main"/>
           <a:p xmlns:a="http://schemas.openxmlformats.org/drawingml/2006/main">
             <a:pPr algn="l">
+              <a:buNone/>
               <a:defRPr sz="1500" b="1">
                 <a:solidFill>
                   <a:srgbClr val="000000"/>

</xml_diff>

<commit_message>
Harden Luna adapter boundaries
</commit_message>
<xml_diff>
--- a/docs/lessons/assets/cah-023-openai-responses-adapter.pptx
+++ b/docs/lessons/assets/cah-023-openai-responses-adapter.pptx
@@ -2,18 +2,18 @@
 <file path=ppt/presentation.xml><?xml version="1.0" encoding="utf-8"?>
 <p:presentation xmlns:p="http://schemas.openxmlformats.org/presentationml/2006/main">
   <p:sldMasterIdLst>
-    <p:sldMasterId xmlns:r="http://schemas.openxmlformats.org/officeDocument/2006/relationships" id="2147483648" r:id="R58d24fbd8b614c88"/>
+    <p:sldMasterId xmlns:r="http://schemas.openxmlformats.org/officeDocument/2006/relationships" id="2147483648" r:id="R4a13e08901e24e26"/>
   </p:sldMasterIdLst>
   <p:notesMasterIdLst>
-    <p:notesMasterId xmlns:r="http://schemas.openxmlformats.org/officeDocument/2006/relationships" r:id="R61e66b5ca0c243aa"/>
+    <p:notesMasterId xmlns:r="http://schemas.openxmlformats.org/officeDocument/2006/relationships" r:id="Reb38c5010aed4d68"/>
   </p:notesMasterIdLst>
   <p:sldIdLst>
-    <p:sldId xmlns:r="http://schemas.openxmlformats.org/officeDocument/2006/relationships" id="256" r:id="Rcc0ce4c34812478b"/>
-    <p:sldId xmlns:r="http://schemas.openxmlformats.org/officeDocument/2006/relationships" id="257" r:id="R5aa19b7e856f4a3d"/>
-    <p:sldId xmlns:r="http://schemas.openxmlformats.org/officeDocument/2006/relationships" id="258" r:id="R8facc10f00874b79"/>
-    <p:sldId xmlns:r="http://schemas.openxmlformats.org/officeDocument/2006/relationships" id="259" r:id="R1d8d91c164374278"/>
-    <p:sldId xmlns:r="http://schemas.openxmlformats.org/officeDocument/2006/relationships" id="260" r:id="R9acecd7355594f44"/>
-    <p:sldId xmlns:r="http://schemas.openxmlformats.org/officeDocument/2006/relationships" id="261" r:id="R746da517ef4c40ce"/>
+    <p:sldId xmlns:r="http://schemas.openxmlformats.org/officeDocument/2006/relationships" id="256" r:id="Rbbe2c878084746ce"/>
+    <p:sldId xmlns:r="http://schemas.openxmlformats.org/officeDocument/2006/relationships" id="257" r:id="Rb69e37d793ab40e7"/>
+    <p:sldId xmlns:r="http://schemas.openxmlformats.org/officeDocument/2006/relationships" id="258" r:id="R9d7183540e124b58"/>
+    <p:sldId xmlns:r="http://schemas.openxmlformats.org/officeDocument/2006/relationships" id="259" r:id="R758050a7f4ca4fd0"/>
+    <p:sldId xmlns:r="http://schemas.openxmlformats.org/officeDocument/2006/relationships" id="260" r:id="R4734d17bb4ed45ce"/>
+    <p:sldId xmlns:r="http://schemas.openxmlformats.org/officeDocument/2006/relationships" id="261" r:id="R8497294fc41e41ed"/>
   </p:sldIdLst>
   <p:sldSz cx="12192000" cy="6858000"/>
   <p:notesSz cx="6858000" cy="9144000"/>
@@ -647,7 +647,7 @@
           <a:lstStyle xmlns:a="http://schemas.openxmlformats.org/drawingml/2006/main"/>
           <a:p xmlns:a="http://schemas.openxmlformats.org/drawingml/2006/main">
             <a:r>
-              <a:t>Contrast the two trust boundaries: the explicit helper admits one local credential into the launched process environment, while only Python consumes it as provider configuration and the request mapper emits the reviewed Luna subset.</a:t>
+              <a:t>Contrast the trust boundaries: --init exclusively creates the ignored owner-only file; the explicit helper admits one key into the launched environment; the TUI strips TLS key logging and starts Python with -E; and Python validates provider configuration before importing the adapter. The request mapper then emits only the reviewed Luna subset.</a:t>
             </a:r>
           </a:p>
           <a:p xmlns:a="http://schemas.openxmlformats.org/drawingml/2006/main">
@@ -663,6 +663,11 @@
           <a:p xmlns:a="http://schemas.openxmlformats.org/drawingml/2006/main">
             <a:r>
               <a:t>- scripts/with-openai-dev-key</a:t>
+            </a:r>
+          </a:p>
+          <a:p xmlns:a="http://schemas.openxmlformats.org/drawingml/2006/main">
+            <a:r>
+              <a:t>- tui/src/runtime-supervisor.ts</a:t>
             </a:r>
           </a:p>
           <a:p xmlns:a="http://schemas.openxmlformats.org/drawingml/2006/main">
@@ -857,7 +862,7 @@
           <a:lstStyle xmlns:a="http://schemas.openxmlformats.org/drawingml/2006/main"/>
           <a:p xmlns:a="http://schemas.openxmlformats.org/drawingml/2006/main">
             <a:r>
-              <a:t>Use the race to reinforce ownership: the adapter owns the resource-cleanup attempt and reports when release cannot be confirmed, while ProviderSession remains the authority for user cancellation, deadlines, and the session terminal.</a:t>
+              <a:t>Use the race to reinforce ownership: the adapter owns resource cleanup, while ProviderSession remains the authority for user cancellation, deadlines, and the session terminal. An independently raised CancelledError from SDK create/read is a bounded provider failure; the same exception from close is a bounded cleanup failure; only cancellation of the owned harness task remains control flow.</a:t>
             </a:r>
           </a:p>
           <a:p xmlns:a="http://schemas.openxmlformats.org/drawingml/2006/main">
@@ -952,7 +957,7 @@
           <a:lstStyle xmlns:a="http://schemas.openxmlformats.org/drawingml/2006/main"/>
           <a:p xmlns:a="http://schemas.openxmlformats.org/drawingml/2006/main">
             <a:r>
-              <a:t>Close by asking the learner to redraw slide 2 from memory and assign each responsibility to one owner. The three evidence facts are repository-backed, not production reliability claims.</a:t>
+              <a:t>Close by asking the learner to redraw slide 2 from memory and assign each responsibility to one owner. The 111 adapter tests are the collected cases in tests/provider/test_openai_responses.py; the three evidence facts are repository-backed, not production reliability claims.</a:t>
             </a:r>
           </a:p>
           <a:p xmlns:a="http://schemas.openxmlformats.org/drawingml/2006/main">
@@ -1065,7 +1070,7 @@
   </p:cSld>
   <p:clrMap bg1="lt1" tx1="dk1" bg2="lt2" tx2="dk2" accent1="accent1" accent2="accent2" accent3="accent3" accent4="accent4" accent5="accent5" accent6="accent6" hlink="hlink" folHlink="folHlink"/>
   <p:sldLayoutIdLst>
-    <p:sldLayoutId xmlns:r="http://schemas.openxmlformats.org/officeDocument/2006/relationships" id="2147483649" r:id="R334936d8325a4bc4"/>
+    <p:sldLayoutId xmlns:r="http://schemas.openxmlformats.org/officeDocument/2006/relationships" id="2147483649" r:id="R9a121b0570124ef2"/>
   </p:sldLayoutIdLst>
   <p:txStyles>
     <p:titleStyle>
@@ -4281,7 +4286,7 @@
                 <a:ea typeface="Helvetica Neue"/>
                 <a:cs typeface="Helvetica Neue"/>
               </a:rPr>
-              <a:t>with-openai-dev-key reads only ignored dev.env.</a:t>
+              <a:t>--init creates ignored dev.env exclusively at 0600.</a:t>
             </a:r>
           </a:p>
           <a:p xmlns:a="http://schemas.openxmlformats.org/drawingml/2006/main">
@@ -4310,7 +4315,7 @@
                 <a:ea typeface="Helvetica Neue"/>
                 <a:cs typeface="Helvetica Neue"/>
               </a:rPr>
-              <a:t>Python validates before importing the adapter.</a:t>
+              <a:t>Python starts with -E; config validates before adapter import.</a:t>
             </a:r>
           </a:p>
         </p:txBody>
@@ -4599,7 +4604,7 @@
                 <a:ea typeface="Helvetica Neue"/>
                 <a:cs typeface="Helvetica Neue"/>
               </a:rPr>
-              <a:t>Boundary rule: dev.env enters the launched environment; only Python consumes it as provider config.</a:t>
+              <a:t>Boundary rule: reject ambient OPENAI_*; strip TLS key logging; only Python consumes provider config.</a:t>
             </a:r>
           </a:p>
         </p:txBody>
@@ -6782,7 +6787,7 @@
                 <a:ea typeface="Helvetica Neue"/>
                 <a:cs typeface="Helvetica Neue"/>
               </a:rPr>
-              <a:t>92</a:t>
+              <a:t>111</a:t>
             </a:r>
           </a:p>
         </p:txBody>
@@ -6896,7 +6901,7 @@
                 <a:ea typeface="Helvetica Neue"/>
                 <a:cs typeface="Helvetica Neue"/>
               </a:rPr>
-              <a:t>Message-only + opaque reasoning, malformed streams, cleanup, races.</a:t>
+              <a:t>Statuses + reasoning; hostile SDK + cleanup cancellation.</a:t>
             </a:r>
           </a:p>
         </p:txBody>

</xml_diff>